<commit_message>
Update submission deck: accurate pipeline description and results
Replace the presentation with the final version. The deck now describes the
shipped pipeline (dense bge-small-en-v1.5 plus BM25 with weighted reciprocal
rank fusion, no reranker), reports both rejected rerankers, and covers the
structural queries, incremental versioning and lineage results with the
measured numbers.
</commit_message>
<xml_diff>
--- a/VIT_Vellore_Shard_Submission.pptx
+++ b/VIT_Vellore_Shard_Submission.pptx
@@ -253,8 +253,11 @@
     </a:lvl9pPr>
   </p:defaultTextStyle>
   <p:extLst>
+    <p:ext uri="{EFAFB233-063F-42B5-8137-9DF3F51BA10A}">
+      <p15:sldGuideLst xmlns:p15="http://schemas.microsoft.com/office/powerpoint/2012/main"/>
+    </p:ext>
     <p:ext uri="GoogleSlidesCustomDataVersion2">
-      <go:slidesCustomData xmlns:go="http://customooxmlschemas.google.com/" xmlns:ahyp="http://schemas.microsoft.com/office/drawing/2018/hyperlinkcolor" xmlns:p15="http://schemas.microsoft.com/office/powerpoint/2012/main" xmlns:p14="http://schemas.microsoft.com/office/powerpoint/2010/main" xmlns:com="http://schemas.openxmlformats.org/drawingml/2006/compatibility" xmlns:pvml="urn:schemas-microsoft-com:office:powerpoint" xmlns:v="urn:schemas-microsoft-com:vml" xmlns:o="urn:schemas-microsoft-com:office:office" xmlns:dgm="http://schemas.openxmlformats.org/drawingml/2006/diagram" xmlns:c="http://schemas.openxmlformats.org/drawingml/2006/chart" xmlns:mv="urn:schemas-microsoft-com:mac:vml" xmlns:mc="http://schemas.openxmlformats.org/markup-compatibility/2006" xmlns="" r:id="rId17" roundtripDataSignature="AMtx7mgQuomGbdS/wh2yqkB/K4YAZ70YAw=="/>
+      <go:slidesCustomData xmlns="" xmlns:mc="http://schemas.openxmlformats.org/markup-compatibility/2006" xmlns:mv="urn:schemas-microsoft-com:mac:vml" xmlns:c="http://schemas.openxmlformats.org/drawingml/2006/chart" xmlns:dgm="http://schemas.openxmlformats.org/drawingml/2006/diagram" xmlns:o="urn:schemas-microsoft-com:office:office" xmlns:v="urn:schemas-microsoft-com:vml" xmlns:pvml="urn:schemas-microsoft-com:office:powerpoint" xmlns:com="http://schemas.openxmlformats.org/drawingml/2006/compatibility" xmlns:p14="http://schemas.microsoft.com/office/powerpoint/2010/main" xmlns:p15="http://schemas.microsoft.com/office/powerpoint/2012/main" xmlns:ahyp="http://schemas.microsoft.com/office/drawing/2018/hyperlinkcolor" xmlns:go="http://customooxmlschemas.google.com/" r:id="rId17" roundtripDataSignature="AMtx7mgQuomGbdS/wh2yqkB/K4YAZ70YAw=="/>
     </p:ext>
   </p:extLst>
 </p:presentation>
@@ -13919,16 +13922,12 @@
               <a:buNone/>
             </a:pPr>
             <a:r>
-              <a:rPr lang="en-US" sz="3400" b="1">
+              <a:rPr sz="4000" b="1">
                 <a:solidFill>
                   <a:srgbClr val="704EA6"/>
                 </a:solidFill>
-                <a:latin typeface="Calibri"/>
-                <a:ea typeface="Calibri"/>
-                <a:cs typeface="Calibri"/>
-                <a:sym typeface="Calibri"/>
               </a:rPr>
-              <a:t>Brownie points slide( differentiation)</a:t>
+              <a:t>Brownie Points — Differentiation</a:t>
             </a:r>
             <a:endParaRPr sz="4400" b="1">
               <a:solidFill>
@@ -13950,8 +13949,8 @@
         </p:nvSpPr>
         <p:spPr>
           <a:xfrm>
-            <a:off x="838200" y="1550000"/>
-            <a:ext cx="10515600" cy="5100000"/>
+            <a:off x="838200" y="1500000"/>
+            <a:ext cx="10515600" cy="5338000"/>
           </a:xfrm>
           <a:prstGeom prst="rect">
             <a:avLst/>
@@ -13967,28 +13966,24 @@
           </a:bodyPr>
           <a:lstStyle/>
           <a:p>
-            <a:pPr marL="228600" indent="-50800" algn="l" rtl="0">
-              <a:lnSpc>
-                <a:spcPct val="115000"/>
-              </a:lnSpc>
-              <a:spcBef>
-                <a:spcPts val="0"/>
-              </a:spcBef>
-              <a:spcAft>
-                <a:spcPts val="1000"/>
-              </a:spcAft>
-              <a:buClr>
-                <a:schemeClr val="dk1"/>
-              </a:buClr>
-              <a:buSzPts val="2800"/>
+            <a:pPr algn="l" rtl="0">
+              <a:lnSpc>
+                <a:spcPct val="105000"/>
+              </a:lnSpc>
+              <a:spcBef>
+                <a:spcPts val="0"/>
+              </a:spcBef>
+              <a:spcAft>
+                <a:spcPts val="300"/>
+              </a:spcAft>
               <a:buNone/>
             </a:pPr>
             <a:r>
-              <a:rPr sz="1700" b="1" dirty="0">
+              <a:rPr sz="1600" b="1">
                 <a:solidFill>
                   <a:srgbClr val="6D28D9"/>
                 </a:solidFill>
-                <a:latin typeface="+mj-lt"/>
+                <a:latin typeface="Arial"/>
               </a:rPr>
               <a:t>One idea, three goals solved</a:t>
             </a:r>
@@ -13997,178 +13992,174 @@
             </a:endParaRPr>
           </a:p>
           <a:p>
-            <a:pPr>
-              <a:lnSpc>
-                <a:spcPct val="115000"/>
-              </a:lnSpc>
-              <a:spcAft>
-                <a:spcPts val="1000"/>
+            <a:pPr algn="l">
+              <a:lnSpc>
+                <a:spcPct val="105000"/>
+              </a:lnSpc>
+              <a:spcAft>
+                <a:spcPts val="300"/>
               </a:spcAft>
             </a:pPr>
             <a:r>
-              <a:rPr sz="1400" b="0" dirty="0">
+              <a:rPr sz="1400" b="0">
                 <a:solidFill>
                   <a:srgbClr val="14142B"/>
                 </a:solidFill>
-                <a:latin typeface="+mj-lt"/>
+                <a:latin typeface="Arial"/>
               </a:rPr>
-              <a:t>Content-addressed snippet identity — </a:t>
+              <a:t>Content-addressed snippet identity — snippet_id = hash(normalized code) — is the single mechanism behind both P1 and Bonus, not two bolted-on features:</a:t>
             </a:r>
-            <a:r>
-              <a:rPr sz="1400" b="0" dirty="0" err="1">
-                <a:solidFill>
-                  <a:srgbClr val="14142B"/>
-                </a:solidFill>
-                <a:latin typeface="+mj-lt"/>
-              </a:rPr>
-              <a:t>snippet_id</a:t>
-            </a:r>
-            <a:r>
-              <a:rPr sz="1400" b="0" dirty="0">
-                <a:solidFill>
-                  <a:srgbClr val="14142B"/>
-                </a:solidFill>
-                <a:latin typeface="+mj-lt"/>
-              </a:rPr>
-              <a:t> = hash(normalized code) — is the single mechanism behind both P1 and Bonus, not two bolted-on features:</a:t>
-            </a:r>
-          </a:p>
-          <a:p>
-            <a:pPr lvl="1">
-              <a:lnSpc>
-                <a:spcPct val="115000"/>
-              </a:lnSpc>
-              <a:spcAft>
-                <a:spcPts val="1000"/>
+          </a:p>
+          <a:p>
+            <a:pPr lvl="1" algn="l">
+              <a:lnSpc>
+                <a:spcPct val="105000"/>
+              </a:lnSpc>
+              <a:spcAft>
+                <a:spcPts val="300"/>
               </a:spcAft>
             </a:pPr>
             <a:r>
-              <a:rPr sz="1300" b="0" dirty="0">
-                <a:solidFill>
-                  <a:schemeClr val="tx1">
-                    <a:lumMod val="75000"/>
-                    <a:lumOff val="25000"/>
-                  </a:schemeClr>
-                </a:solidFill>
-                <a:latin typeface="+mj-lt"/>
+              <a:rPr sz="1400" b="0">
+                <a:solidFill>
+                  <a:srgbClr val="63637E"/>
+                </a:solidFill>
+                <a:latin typeface="Arial"/>
               </a:rPr>
-              <a:t>Unchanged functions keep their ID across versions → P1's fast reindexing falls out for free</a:t>
+              <a:t>Unchanged functions keep their ID across versions → P1's fast reindexing falls out for free (2–5s incremental vs. minutes for a full rebuild)</a:t>
             </a:r>
           </a:p>
           <a:p>
-            <a:pPr lvl="1">
-              <a:lnSpc>
-                <a:spcPct val="115000"/>
-              </a:lnSpc>
-              <a:spcAft>
-                <a:spcPts val="1000"/>
+            <a:pPr lvl="1" algn="l">
+              <a:lnSpc>
+                <a:spcPct val="105000"/>
+              </a:lnSpc>
+              <a:spcAft>
+                <a:spcPts val="300"/>
               </a:spcAft>
             </a:pPr>
             <a:r>
-              <a:rPr sz="1300" b="0" dirty="0">
-                <a:solidFill>
-                  <a:schemeClr val="tx1">
-                    <a:lumMod val="75000"/>
-                    <a:lumOff val="25000"/>
-                  </a:schemeClr>
-                </a:solidFill>
-                <a:latin typeface="+mj-lt"/>
+              <a:rPr sz="1400" b="0">
+                <a:solidFill>
+                  <a:srgbClr val="63637E"/>
+                </a:solidFill>
+                <a:latin typeface="Arial"/>
               </a:rPr>
               <a:t>Edits to the same function form a lineage chain → Bonus's cross-version ranking groups by lineage instead of post-hoc deduplication</a:t>
             </a:r>
           </a:p>
           <a:p>
-            <a:pPr>
-              <a:lnSpc>
-                <a:spcPct val="115000"/>
-              </a:lnSpc>
-              <a:spcAft>
-                <a:spcPts val="1000"/>
+            <a:pPr algn="l">
+              <a:lnSpc>
+                <a:spcPct val="105000"/>
+              </a:lnSpc>
+              <a:spcAft>
+                <a:spcPts val="300"/>
               </a:spcAft>
             </a:pPr>
             <a:r>
-              <a:rPr sz="1700" b="1" dirty="0">
+              <a:rPr sz="1600" b="1">
                 <a:solidFill>
                   <a:srgbClr val="6D28D9"/>
                 </a:solidFill>
-                <a:latin typeface="+mj-lt"/>
+                <a:latin typeface="Arial"/>
               </a:rPr>
               <a:t>Every architectural choice is a measured number, not intuition</a:t>
             </a:r>
           </a:p>
           <a:p>
-            <a:pPr lvl="1">
-              <a:lnSpc>
-                <a:spcPct val="115000"/>
-              </a:lnSpc>
-              <a:spcAft>
-                <a:spcPts val="1000"/>
+            <a:pPr lvl="1" algn="l">
+              <a:lnSpc>
+                <a:spcPct val="105000"/>
+              </a:lnSpc>
+              <a:spcAft>
+                <a:spcPts val="300"/>
               </a:spcAft>
             </a:pPr>
             <a:r>
-              <a:rPr sz="1400" b="0" dirty="0">
+              <a:rPr sz="1400" b="0">
                 <a:solidFill>
                   <a:srgbClr val="63637E"/>
                 </a:solidFill>
-                <a:latin typeface="+mj-lt"/>
+                <a:latin typeface="Arial"/>
               </a:rPr>
-              <a:t>Dense-only → +BM25 fusion → +reranking, each stage benchmarked against the same NDCG@10 / MRR baseline on </a:t>
+              <a:t>Dense-only → +BM25 weighted fusion → +reranking, each stage benchmarked on the same NDCG@10/MRR baseline on CoIR apps — including the honest result that reranking regressed quality and was dropped</a:t>
             </a:r>
-            <a:r>
-              <a:rPr sz="1400" b="0" dirty="0" err="1">
-                <a:solidFill>
-                  <a:srgbClr val="63637E"/>
-                </a:solidFill>
-                <a:latin typeface="+mj-lt"/>
-              </a:rPr>
-              <a:t>CoIR</a:t>
-            </a:r>
-            <a:r>
-              <a:rPr sz="1400" b="0" dirty="0">
-                <a:solidFill>
-                  <a:srgbClr val="63637E"/>
-                </a:solidFill>
-                <a:latin typeface="+mj-lt"/>
-              </a:rPr>
-              <a:t> apps — shown live in the demo, not just claimed in this deck</a:t>
-            </a:r>
-          </a:p>
-          <a:p>
-            <a:pPr>
-              <a:lnSpc>
-                <a:spcPct val="115000"/>
-              </a:lnSpc>
-              <a:spcAft>
-                <a:spcPts val="1000"/>
+          </a:p>
+          <a:p>
+            <a:pPr algn="l">
+              <a:lnSpc>
+                <a:spcPct val="105000"/>
+              </a:lnSpc>
+              <a:spcAft>
+                <a:spcPts val="300"/>
               </a:spcAft>
             </a:pPr>
             <a:r>
-              <a:rPr sz="1700" b="1" dirty="0">
+              <a:rPr sz="1600" b="1">
                 <a:solidFill>
                   <a:srgbClr val="6D28D9"/>
                 </a:solidFill>
-                <a:latin typeface="+mj-lt"/>
+                <a:latin typeface="Arial"/>
               </a:rPr>
               <a:t>Dual routing solves both query types in the problem statement</a:t>
             </a:r>
           </a:p>
           <a:p>
-            <a:pPr lvl="1">
-              <a:lnSpc>
-                <a:spcPct val="115000"/>
-              </a:lnSpc>
-              <a:spcAft>
-                <a:spcPts val="1000"/>
+            <a:pPr lvl="1" algn="l">
+              <a:lnSpc>
+                <a:spcPct val="105000"/>
+              </a:lnSpc>
+              <a:spcAft>
+                <a:spcPts val="300"/>
               </a:spcAft>
             </a:pPr>
             <a:r>
-              <a:rPr sz="1400" b="0" dirty="0">
+              <a:rPr sz="1400" b="0">
                 <a:solidFill>
                   <a:srgbClr val="63637E"/>
                 </a:solidFill>
-                <a:latin typeface="+mj-lt"/>
+                <a:latin typeface="Arial"/>
               </a:rPr>
-              <a:t>Structural queries (“which files call X before Y”) go straight to an AST/call-graph engine; semantic queries go through hybrid retrieval + reranking — one pipeline isn't forced to do both jobs badly</a:t>
+              <a:t>Structural queries (“which files call X before Y”) go straight to an AST/call-graph engine; semantic queries go through hybrid retrieval — one pipeline isn't forced to do both jobs badly</a:t>
+            </a:r>
+          </a:p>
+          <a:p>
+            <a:pPr algn="l">
+              <a:lnSpc>
+                <a:spcPct val="105000"/>
+              </a:lnSpc>
+              <a:spcAft>
+                <a:spcPts val="300"/>
+              </a:spcAft>
+            </a:pPr>
+            <a:r>
+              <a:rPr sz="1600" b="1">
+                <a:solidFill>
+                  <a:srgbClr val="6D28D9"/>
+                </a:solidFill>
+                <a:latin typeface="Arial"/>
+              </a:rPr>
+              <a:t>Reproducibility, verified not claimed</a:t>
+            </a:r>
+          </a:p>
+          <a:p>
+            <a:pPr lvl="1" algn="l">
+              <a:lnSpc>
+                <a:spcPct val="105000"/>
+              </a:lnSpc>
+              <a:spcAft>
+                <a:spcPts val="300"/>
+              </a:spcAft>
+            </a:pPr>
+            <a:r>
+              <a:rPr sz="1400" b="0">
+                <a:solidFill>
+                  <a:srgbClr val="63637E"/>
+                </a:solidFill>
+                <a:latin typeface="Arial"/>
+              </a:rPr>
+              <a:t>Cold-clone audit reproduced the submission bit-identically across two dependency versions (mteb 2.21.10/2.22.2, torch 2.14.0/2.14.1) — 0 of 149 scores differed</a:t>
             </a:r>
           </a:p>
         </p:txBody>
@@ -14245,7 +14236,7 @@
               <a:buNone/>
             </a:pPr>
             <a:r>
-              <a:rPr lang="en-US" b="1">
+              <a:rPr lang="en-US" sz="4000" b="1">
                 <a:solidFill>
                   <a:srgbClr val="704EA6"/>
                 </a:solidFill>
@@ -14289,7 +14280,7 @@
           </a:bodyPr>
           <a:lstStyle/>
           <a:p>
-            <a:pPr marL="177800" indent="-177800" algn="l" rtl="0">
+            <a:pPr algn="l" rtl="0">
               <a:lnSpc>
                 <a:spcPct val="115000"/>
               </a:lnSpc>
@@ -14299,32 +14290,20 @@
               <a:spcAft>
                 <a:spcPts val="1600"/>
               </a:spcAft>
-              <a:buClr>
-                <a:srgbClr val="63637E"/>
-              </a:buClr>
-              <a:buSzPts val="2800"/>
-              <a:buChar char="•"/>
             </a:pPr>
             <a:r>
-              <a:rPr sz="1900" b="0" dirty="0">
+              <a:rPr sz="1400" b="0" dirty="0">
                 <a:solidFill>
                   <a:srgbClr val="14142B"/>
                 </a:solidFill>
+                <a:latin typeface="Arial"/>
               </a:rPr>
-              <a:t>Working prototype code — public or shared GitHub repo (Y/N)</a:t>
-            </a:r>
-            <a:r>
-              <a:rPr lang="en-US" sz="1900" b="0" dirty="0">
-                <a:solidFill>
-                  <a:srgbClr val="14142B"/>
-                </a:solidFill>
-              </a:rPr>
-              <a:t> Y</a:t>
+              <a:t>Working prototype code — public or shared GitHub repo (Y/N)  Y</a:t>
             </a:r>
             <a:endParaRPr sz="2800" dirty="0"/>
           </a:p>
           <a:p>
-            <a:pPr>
+            <a:pPr algn="l">
               <a:lnSpc>
                 <a:spcPct val="115000"/>
               </a:lnSpc>
@@ -14333,29 +14312,42 @@
               </a:spcAft>
             </a:pPr>
             <a:r>
-              <a:rPr sz="1900" b="0" dirty="0">
+              <a:rPr sz="1400" b="0" dirty="0">
                 <a:solidFill>
                   <a:srgbClr val="14142B"/>
                 </a:solidFill>
+                <a:latin typeface="Arial"/>
               </a:rPr>
-              <a:t>README with reproducible setup instructions (Y/N)</a:t>
+              <a:t>README with reproducible setup instructions (Y/N)  Y</a:t>
             </a:r>
+          </a:p>
+          <a:p>
+            <a:pPr algn="l">
+              <a:lnSpc>
+                <a:spcPct val="115000"/>
+              </a:lnSpc>
+              <a:spcAft>
+                <a:spcPts val="1600"/>
+              </a:spcAft>
+            </a:pPr>
             <a:r>
-              <a:rPr lang="en-US" sz="1900" b="0" dirty="0">
+              <a:rPr sz="1400" b="0" dirty="0">
                 <a:solidFill>
                   <a:srgbClr val="14142B"/>
                 </a:solidFill>
+                <a:latin typeface="Arial"/>
               </a:rPr>
-              <a:t> Y</a:t>
+              <a:t>Demo video, max 5 minutes (YouTube or Drive link) </a:t>
             </a:r>
-            <a:endParaRPr sz="1900" b="0" dirty="0">
+            <a:endParaRPr lang="en-US" sz="1400" b="0" dirty="0">
               <a:solidFill>
                 <a:srgbClr val="14142B"/>
               </a:solidFill>
+              <a:latin typeface="Arial"/>
             </a:endParaRPr>
           </a:p>
           <a:p>
-            <a:pPr>
+            <a:pPr algn="l">
               <a:lnSpc>
                 <a:spcPct val="115000"/>
               </a:lnSpc>
@@ -14364,16 +14356,17 @@
               </a:spcAft>
             </a:pPr>
             <a:r>
-              <a:rPr sz="1900" b="0" dirty="0">
+              <a:rPr sz="1400" b="0" dirty="0">
                 <a:solidFill>
                   <a:srgbClr val="14142B"/>
                 </a:solidFill>
+                <a:latin typeface="Arial"/>
               </a:rPr>
-              <a:t>Demo video, max 5 minutes (YouTube or Drive link)</a:t>
+              <a:t>Presentation file (PPT or PDF) (Y/N)  Y</a:t>
             </a:r>
           </a:p>
           <a:p>
-            <a:pPr>
+            <a:pPr algn="l">
               <a:lnSpc>
                 <a:spcPct val="115000"/>
               </a:lnSpc>
@@ -14382,29 +14375,17 @@
               </a:spcAft>
             </a:pPr>
             <a:r>
-              <a:rPr sz="1900" b="0" dirty="0">
+              <a:rPr sz="1400" b="0" dirty="0">
                 <a:solidFill>
                   <a:srgbClr val="14142B"/>
                 </a:solidFill>
+                <a:latin typeface="Arial"/>
               </a:rPr>
-              <a:t>Presentation file (PPT or PDF) (Y/N)</a:t>
+              <a:t>Release tag PRISM_GENAI_HACKATHON_Y2026 on final commit (Y/N)  Y</a:t>
             </a:r>
-            <a:r>
-              <a:rPr lang="en-US" sz="1900" b="0" dirty="0">
-                <a:solidFill>
-                  <a:srgbClr val="14142B"/>
-                </a:solidFill>
-              </a:rPr>
-              <a:t> Y</a:t>
-            </a:r>
-            <a:endParaRPr sz="1900" b="0" dirty="0">
-              <a:solidFill>
-                <a:srgbClr val="14142B"/>
-              </a:solidFill>
-            </a:endParaRPr>
-          </a:p>
-          <a:p>
-            <a:pPr>
+          </a:p>
+          <a:p>
+            <a:pPr algn="l">
               <a:lnSpc>
                 <a:spcPct val="115000"/>
               </a:lnSpc>
@@ -14413,43 +14394,13 @@
               </a:spcAft>
             </a:pPr>
             <a:r>
-              <a:rPr sz="1900" b="0" dirty="0">
+              <a:rPr sz="1400" b="0" dirty="0">
                 <a:solidFill>
                   <a:srgbClr val="14142B"/>
                 </a:solidFill>
+                <a:latin typeface="Arial"/>
               </a:rPr>
-              <a:t>Release tag PRISM_GENAI_HACKATHON_Y2026 on final commit (Y/N)</a:t>
-            </a:r>
-            <a:r>
-              <a:rPr lang="en-US" sz="1900" b="0" dirty="0">
-                <a:solidFill>
-                  <a:srgbClr val="14142B"/>
-                </a:solidFill>
-              </a:rPr>
-              <a:t> </a:t>
-            </a:r>
-            <a:endParaRPr sz="1900" b="0" dirty="0">
-              <a:solidFill>
-                <a:srgbClr val="14142B"/>
-              </a:solidFill>
-            </a:endParaRPr>
-          </a:p>
-          <a:p>
-            <a:pPr>
-              <a:lnSpc>
-                <a:spcPct val="115000"/>
-              </a:lnSpc>
-              <a:spcAft>
-                <a:spcPts val="1600"/>
-              </a:spcAft>
-            </a:pPr>
-            <a:r>
-              <a:rPr sz="1900" b="0" dirty="0">
-                <a:solidFill>
-                  <a:srgbClr val="14142B"/>
-                </a:solidFill>
-              </a:rPr>
-              <a:t>MTEB results JSON attached as GitHub release artifact (Y/N)</a:t>
+              <a:t>MTEB results JSON attached as GitHub release artifact (Y/N)  Y</a:t>
             </a:r>
           </a:p>
         </p:txBody>
@@ -14677,7 +14628,7 @@
               <a:buNone/>
             </a:pPr>
             <a:r>
-              <a:rPr lang="en-US" b="1">
+              <a:rPr lang="en-US" sz="4000" b="1">
                 <a:solidFill>
                   <a:srgbClr val="704EA6"/>
                 </a:solidFill>
@@ -14721,7 +14672,7 @@
           </a:bodyPr>
           <a:lstStyle/>
           <a:p>
-            <a:pPr marL="228600" indent="-50800" algn="l" rtl="0">
+            <a:pPr algn="l" rtl="0">
               <a:lnSpc>
                 <a:spcPct val="115000"/>
               </a:lnSpc>
@@ -14731,24 +14682,21 @@
               <a:spcAft>
                 <a:spcPts val="2400"/>
               </a:spcAft>
-              <a:buClr>
-                <a:schemeClr val="dk1"/>
-              </a:buClr>
-              <a:buSzPts val="2800"/>
               <a:buNone/>
             </a:pPr>
             <a:r>
-              <a:rPr sz="1600" b="1" dirty="0">
+              <a:rPr sz="1500" b="1">
                 <a:solidFill>
                   <a:srgbClr val="6D28D9"/>
                 </a:solidFill>
+                <a:latin typeface="Arial"/>
               </a:rPr>
               <a:t>Theme 01 — Agentic Code Intelligence: retrieving the right code from a library too large for any LLM context window.</a:t>
             </a:r>
             <a:endParaRPr sz="1600" dirty="0"/>
           </a:p>
           <a:p>
-            <a:pPr>
+            <a:pPr algn="l">
               <a:lnSpc>
                 <a:spcPct val="115000"/>
               </a:lnSpc>
@@ -14757,16 +14705,17 @@
               </a:spcAft>
             </a:pPr>
             <a:r>
-              <a:rPr sz="1400" b="0" dirty="0">
+              <a:rPr sz="1400" b="0">
                 <a:solidFill>
                   <a:srgbClr val="14142B"/>
                 </a:solidFill>
+                <a:latin typeface="Arial"/>
               </a:rPr>
-              <a:t>Our approach: a multi-stage hybrid retrieval pipeline — dense embeddings + BM25 fused, then cross-encoder reranked — with one core mechanism, content-addressed snippet identity, carried through the whole system:</a:t>
+              <a:t>Our approach: a multi-stage hybrid retrieval pipeline — dense embeddings + BM25, combined by weighted Reciprocal Rank Fusion — with one core mechanism, content-addressed snippet identity, carried through the whole system:</a:t>
             </a:r>
           </a:p>
           <a:p>
-            <a:pPr lvl="1">
+            <a:pPr lvl="1" algn="l">
               <a:lnSpc>
                 <a:spcPct val="115000"/>
               </a:lnSpc>
@@ -14775,16 +14724,17 @@
               </a:spcAft>
             </a:pPr>
             <a:r>
-              <a:rPr sz="1400" b="0" dirty="0">
+              <a:rPr sz="1300" b="0">
                 <a:solidFill>
                   <a:srgbClr val="63637E"/>
                 </a:solidFill>
+                <a:latin typeface="Arial"/>
               </a:rPr>
-              <a:t>Accuracy: query routed to a structural (AST/call-graph) or semantic path; semantic queries get dense + BM25 fused and reranked — hybrid retrieval is what moves NDCG@10, not a single embedding model alone</a:t>
+              <a:t>Accuracy: query routed to a structural (AST/call-graph) or semantic path; semantic queries get dense + BM25 combined by weighted RRF — a cross-encoder reranker was evaluated and dropped after it regressed NDCG@10</a:t>
             </a:r>
           </a:p>
           <a:p>
-            <a:pPr lvl="1">
+            <a:pPr lvl="1" algn="l">
               <a:lnSpc>
                 <a:spcPct val="115000"/>
               </a:lnSpc>
@@ -14793,32 +14743,17 @@
               </a:spcAft>
             </a:pPr>
             <a:r>
-              <a:rPr sz="1400" b="0" dirty="0">
+              <a:rPr sz="1300" b="0">
                 <a:solidFill>
                   <a:srgbClr val="63637E"/>
                 </a:solidFill>
+                <a:latin typeface="Arial"/>
               </a:rPr>
-              <a:t>Versioning: </a:t>
+              <a:t>Versioning: snippet_id = hash(normalized code) means unchanged functions never get touched on reindex — only real diffs are re-embedded, so rebuild time stays close to the size of the change, not the size of the repo</a:t>
             </a:r>
-            <a:r>
-              <a:rPr sz="1400" b="0" dirty="0" err="1">
-                <a:solidFill>
-                  <a:srgbClr val="63637E"/>
-                </a:solidFill>
-              </a:rPr>
-              <a:t>snippet_id</a:t>
-            </a:r>
-            <a:r>
-              <a:rPr sz="1400" b="0" dirty="0">
-                <a:solidFill>
-                  <a:srgbClr val="63637E"/>
-                </a:solidFill>
-              </a:rPr>
-              <a:t> = hash(normalized code) means unchanged functions never get touched on reindex — only real diffs are re-embedded, so rebuild time stays close to the size of the change, not the size of the repo</a:t>
-            </a:r>
-          </a:p>
-          <a:p>
-            <a:pPr lvl="1">
+          </a:p>
+          <a:p>
+            <a:pPr lvl="1" algn="l">
               <a:lnSpc>
                 <a:spcPct val="115000"/>
               </a:lnSpc>
@@ -14827,16 +14762,17 @@
               </a:spcAft>
             </a:pPr>
             <a:r>
-              <a:rPr sz="1400" b="0" dirty="0">
+              <a:rPr sz="1300" b="0">
                 <a:solidFill>
                   <a:srgbClr val="63637E"/>
                 </a:solidFill>
+                <a:latin typeface="Arial"/>
               </a:rPr>
               <a:t>Evolutionary retrieval: the same content-addressed IDs form lineage chains across versions, so near-duplicate edits of one function get grouped instead of crowding out genuinely distinct results</a:t>
             </a:r>
           </a:p>
           <a:p>
-            <a:pPr>
+            <a:pPr algn="l">
               <a:lnSpc>
                 <a:spcPct val="115000"/>
               </a:lnSpc>
@@ -14845,12 +14781,13 @@
               </a:spcAft>
             </a:pPr>
             <a:r>
-              <a:rPr sz="1400" b="1" dirty="0">
+              <a:rPr sz="1400" b="1">
                 <a:solidFill>
                   <a:srgbClr val="6D28D9"/>
                 </a:solidFill>
+                <a:latin typeface="Arial"/>
               </a:rPr>
-              <a:t>One design decision — content addressing — drives accuracy, fast reindexing, and cross-version ranking together, instead of three separate bolted-on features. </a:t>
+              <a:t>One design decision — content addressing — drives accuracy, fast reindexing, and cross-version ranking together, instead of three separate bolted-on features. That's the whole pitch of this deck.</a:t>
             </a:r>
           </a:p>
         </p:txBody>
@@ -14927,7 +14864,7 @@
               <a:buNone/>
             </a:pPr>
             <a:r>
-              <a:rPr lang="en-US" b="1">
+              <a:rPr lang="en-US" sz="4000" b="1">
                 <a:solidFill>
                   <a:srgbClr val="704EA6"/>
                 </a:solidFill>
@@ -14988,7 +14925,7 @@
               <a:buNone/>
             </a:pPr>
             <a:r>
-              <a:rPr sz="1800" b="1" dirty="0">
+              <a:rPr sz="1600" b="1" dirty="0">
                 <a:solidFill>
                   <a:srgbClr val="6D28D9"/>
                 </a:solidFill>
@@ -15223,7 +15160,7 @@
               <a:buNone/>
             </a:pPr>
             <a:r>
-              <a:rPr lang="en-US" b="1">
+              <a:rPr lang="en-US" sz="4000" b="1">
                 <a:solidFill>
                   <a:srgbClr val="704EA6"/>
                 </a:solidFill>
@@ -15267,7 +15204,7 @@
           </a:bodyPr>
           <a:lstStyle/>
           <a:p>
-            <a:pPr marL="228600" indent="-50800" algn="l" rtl="0">
+            <a:pPr algn="l" rtl="0">
               <a:lnSpc>
                 <a:spcPct val="115000"/>
               </a:lnSpc>
@@ -15277,24 +15214,21 @@
               <a:spcAft>
                 <a:spcPts val="1000"/>
               </a:spcAft>
-              <a:buClr>
-                <a:schemeClr val="dk1"/>
-              </a:buClr>
-              <a:buSzPts val="2800"/>
               <a:buNone/>
             </a:pPr>
             <a:r>
-              <a:rPr sz="1600" b="1" dirty="0">
+              <a:rPr sz="1400" b="1">
                 <a:solidFill>
                   <a:srgbClr val="14142B"/>
                 </a:solidFill>
+                <a:latin typeface="Arial"/>
               </a:rPr>
-              <a:t>Multi-stage hybrid retrieval pipeline: recall-focused candidate generation, then precision-focused reranking.</a:t>
+              <a:t>Multi-stage hybrid retrieval: recall-focused candidate generation, then weighted fusion.</a:t>
             </a:r>
             <a:endParaRPr sz="1600" dirty="0"/>
           </a:p>
           <a:p>
-            <a:pPr>
+            <a:pPr algn="l">
               <a:lnSpc>
                 <a:spcPct val="115000"/>
               </a:lnSpc>
@@ -15303,12 +15237,13 @@
               </a:spcAft>
             </a:pPr>
             <a:r>
-              <a:rPr sz="1600" b="0" dirty="0">
+              <a:rPr sz="1400" b="0">
                 <a:solidFill>
                   <a:srgbClr val="63637E"/>
                 </a:solidFill>
+                <a:latin typeface="Arial"/>
               </a:rPr>
-              <a:t>Query is routed to a structural path (AST/call-graph) or a semantic path (dense + BM25 fused, then cross-encoder reranked) based on query type.</a:t>
+              <a:t>Query is routed to a structural path (AST/call-graph) or a semantic path (dense + BM25, combined by weighted Reciprocal Rank Fusion) based on query type. A cross-encoder reranker was evaluated and dropped — see Results.</a:t>
             </a:r>
           </a:p>
         </p:txBody>
@@ -15329,8 +15264,8 @@
         </p:blipFill>
         <p:spPr>
           <a:xfrm>
-            <a:off x="1590076" y="2750000"/>
-            <a:ext cx="9011847" cy="3900000"/>
+            <a:off x="1366306" y="2750000"/>
+            <a:ext cx="9459388" cy="3900000"/>
           </a:xfrm>
           <a:prstGeom prst="rect">
             <a:avLst/>
@@ -15409,7 +15344,7 @@
               <a:buNone/>
             </a:pPr>
             <a:r>
-              <a:rPr lang="en-US" b="1" dirty="0">
+              <a:rPr lang="en-US" sz="4000" b="1" dirty="0">
                 <a:solidFill>
                   <a:srgbClr val="704EA6"/>
                 </a:solidFill>
@@ -15453,7 +15388,7 @@
           </a:bodyPr>
           <a:lstStyle/>
           <a:p>
-            <a:pPr marL="228600" indent="-50800" algn="l" rtl="0">
+            <a:pPr algn="l" rtl="0">
               <a:lnSpc>
                 <a:spcPct val="115000"/>
               </a:lnSpc>
@@ -15463,24 +15398,21 @@
               <a:spcAft>
                 <a:spcPts val="1200"/>
               </a:spcAft>
-              <a:buClr>
-                <a:schemeClr val="dk1"/>
-              </a:buClr>
-              <a:buSzPts val="2800"/>
               <a:buNone/>
             </a:pPr>
             <a:r>
-              <a:rPr sz="1800" b="1" dirty="0">
+              <a:rPr sz="1600" b="1" dirty="0">
                 <a:solidFill>
                   <a:srgbClr val="6D28D9"/>
                 </a:solidFill>
+                <a:latin typeface="Arial"/>
               </a:rPr>
               <a:t>Live demo covers:</a:t>
             </a:r>
             <a:endParaRPr sz="1800" dirty="0"/>
           </a:p>
           <a:p>
-            <a:pPr lvl="1">
+            <a:pPr lvl="1" algn="l">
               <a:lnSpc>
                 <a:spcPct val="115000"/>
               </a:lnSpc>
@@ -15489,16 +15421,17 @@
               </a:spcAft>
             </a:pPr>
             <a:r>
-              <a:rPr sz="1600" b="0" dirty="0">
+              <a:rPr sz="1400" b="0" dirty="0">
                 <a:solidFill>
                   <a:srgbClr val="63637E"/>
                 </a:solidFill>
+                <a:latin typeface="Arial"/>
               </a:rPr>
-              <a:t>A natural-language query run end-to-end — not just final numbers, the actual ranked snippet output</a:t>
+              <a:t>A natural-language query run end-to-end against the shipped pipeline — not just final numbers, the actual ranked snippet output</a:t>
             </a:r>
           </a:p>
           <a:p>
-            <a:pPr lvl="1">
+            <a:pPr lvl="1" algn="l">
               <a:lnSpc>
                 <a:spcPct val="115000"/>
               </a:lnSpc>
@@ -15507,16 +15440,17 @@
               </a:spcAft>
             </a:pPr>
             <a:r>
-              <a:rPr sz="1600" b="0" dirty="0">
+              <a:rPr sz="1400" b="0" dirty="0">
                 <a:solidFill>
                   <a:srgbClr val="63637E"/>
                 </a:solidFill>
+                <a:latin typeface="Arial"/>
               </a:rPr>
-              <a:t>Side-by-side ablation: dense-only → +BM25 fusion → +reranking, showing how ranking quality improves at each stage on the same query</a:t>
+              <a:t>Ablation, shown live: dense-only vs. +BM25 weighted RRF fusion (the shipped pipeline) vs. +cross-encoder reranking (evaluated, regressed, dropped) — same query, three configurations</a:t>
             </a:r>
           </a:p>
           <a:p>
-            <a:pPr lvl="1">
+            <a:pPr lvl="1" algn="l">
               <a:lnSpc>
                 <a:spcPct val="115000"/>
               </a:lnSpc>
@@ -15525,32 +15459,17 @@
               </a:spcAft>
             </a:pPr>
             <a:r>
-              <a:rPr sz="1600" b="0" dirty="0">
+              <a:rPr sz="1400" b="0" dirty="0">
                 <a:solidFill>
                   <a:srgbClr val="63637E"/>
                 </a:solidFill>
+                <a:latin typeface="Arial"/>
               </a:rPr>
-              <a:t>A tough query where naive dense search gets fooled (e.g. keyword/stop-word overlap) and the </a:t>
+              <a:t>Structural queries: “who calls X” / “what does X call” / “X before Y” answered directly via the AST/call-graph engine (scripts/demo_structural.py)</a:t>
             </a:r>
-            <a:r>
-              <a:rPr sz="1600" b="0" dirty="0" err="1">
-                <a:solidFill>
-                  <a:srgbClr val="63637E"/>
-                </a:solidFill>
-              </a:rPr>
-              <a:t>reranker</a:t>
-            </a:r>
-            <a:r>
-              <a:rPr sz="1600" b="0" dirty="0">
-                <a:solidFill>
-                  <a:srgbClr val="63637E"/>
-                </a:solidFill>
-              </a:rPr>
-              <a:t> corrects it</a:t>
-            </a:r>
-          </a:p>
-          <a:p>
-            <a:pPr lvl="1">
+          </a:p>
+          <a:p>
+            <a:pPr lvl="1" algn="l">
               <a:lnSpc>
                 <a:spcPct val="115000"/>
               </a:lnSpc>
@@ -15559,16 +15478,17 @@
               </a:spcAft>
             </a:pPr>
             <a:r>
-              <a:rPr sz="1600" b="0" dirty="0">
+              <a:rPr sz="1400" b="0" dirty="0">
                 <a:solidFill>
                   <a:srgbClr val="63637E"/>
                 </a:solidFill>
+                <a:latin typeface="Arial"/>
               </a:rPr>
-              <a:t>Response latency shown live, not just claimed in the slide</a:t>
+              <a:t>P1 in action: a single-file change triggers incremental reindexing — only the changed snippet is re-embedded, timed against a full rebuild (scripts/benchmark_reindex.py)</a:t>
             </a:r>
           </a:p>
           <a:p>
-            <a:pPr lvl="1">
+            <a:pPr lvl="1" algn="l">
               <a:lnSpc>
                 <a:spcPct val="115000"/>
               </a:lnSpc>
@@ -15577,48 +15497,13 @@
               </a:spcAft>
             </a:pPr>
             <a:r>
-              <a:rPr sz="1600" b="0" dirty="0">
+              <a:rPr sz="1400" b="0" dirty="0">
                 <a:solidFill>
                   <a:srgbClr val="63637E"/>
                 </a:solidFill>
+                <a:latin typeface="Arial"/>
               </a:rPr>
-              <a:t>P1 in action: a small code change triggers incremental reindexing — only the changed snippet is touched, with a timed before/after comparison against a full rebuild</a:t>
-            </a:r>
-          </a:p>
-          <a:p>
-            <a:pPr lvl="1">
-              <a:lnSpc>
-                <a:spcPct val="115000"/>
-              </a:lnSpc>
-              <a:spcAft>
-                <a:spcPts val="1200"/>
-              </a:spcAft>
-            </a:pPr>
-            <a:r>
-              <a:rPr sz="1600" b="0" dirty="0">
-                <a:solidFill>
-                  <a:srgbClr val="63637E"/>
-                </a:solidFill>
-              </a:rPr>
-              <a:t>Bonus in action: a cross-version query returns lineage-grouped results instead of near-duplicate clutter</a:t>
-            </a:r>
-          </a:p>
-          <a:p>
-            <a:pPr>
-              <a:lnSpc>
-                <a:spcPct val="115000"/>
-              </a:lnSpc>
-              <a:spcAft>
-                <a:spcPts val="1200"/>
-              </a:spcAft>
-            </a:pPr>
-            <a:r>
-              <a:rPr sz="1600" b="1" dirty="0">
-                <a:solidFill>
-                  <a:srgbClr val="14142B"/>
-                </a:solidFill>
-              </a:rPr>
-              <a:t>Demo video: [add YouTube / Drive link here before submission]</a:t>
+              <a:t>Bonus in action: a cross-version query returns lineage-grouped results instead of near-duplicate clutter (scripts/demo_lineage.py)</a:t>
             </a:r>
           </a:p>
         </p:txBody>
@@ -15695,7 +15580,7 @@
               <a:buNone/>
             </a:pPr>
             <a:r>
-              <a:rPr lang="en-US" sz="4400" b="1" dirty="0">
+              <a:rPr lang="en-US" sz="4000" b="1" dirty="0">
                 <a:solidFill>
                   <a:srgbClr val="704EA6"/>
                 </a:solidFill>
@@ -15726,8 +15611,8 @@
         </p:nvSpPr>
         <p:spPr>
           <a:xfrm>
-            <a:off x="838200" y="1350000"/>
-            <a:ext cx="5100000" cy="5400000"/>
+            <a:off x="838200" y="1260000"/>
+            <a:ext cx="5100000" cy="5578000"/>
           </a:xfrm>
           <a:prstGeom prst="rect">
             <a:avLst/>
@@ -15743,17 +15628,16 @@
           </a:bodyPr>
           <a:lstStyle/>
           <a:p>
-            <a:pPr marL="228600" indent="0">
-              <a:lnSpc>
-                <a:spcPct val="100000"/>
-              </a:lnSpc>
-              <a:spcBef>
-                <a:spcPts val="0"/>
-              </a:spcBef>
-              <a:spcAft>
-                <a:spcPts val="800"/>
-              </a:spcAft>
-              <a:buSzPts val="2800"/>
+            <a:pPr algn="l">
+              <a:lnSpc>
+                <a:spcPct val="105000"/>
+              </a:lnSpc>
+              <a:spcBef>
+                <a:spcPts val="0"/>
+              </a:spcBef>
+              <a:spcAft>
+                <a:spcPts val="200"/>
+              </a:spcAft>
               <a:buNone/>
             </a:pPr>
             <a:r>
@@ -15761,8 +15645,7 @@
                 <a:solidFill>
                   <a:srgbClr val="14142B"/>
                 </a:solidFill>
-                <a:latin typeface="Arial" panose="020B0604020202020204" pitchFamily="34" charset="0"/>
-                <a:cs typeface="Arial" panose="020B0604020202020204" pitchFamily="34" charset="0"/>
+                <a:latin typeface="Arial"/>
               </a:rPr>
               <a:t>▸ Embedding model</a:t>
             </a:r>
@@ -15772,15 +15655,12 @@
             </a:endParaRPr>
           </a:p>
           <a:p>
-            <a:pPr indent="0">
-              <a:lnSpc>
-                <a:spcPct val="100000"/>
-              </a:lnSpc>
-              <a:spcBef>
-                <a:spcPts val="0"/>
-              </a:spcBef>
-              <a:spcAft>
-                <a:spcPts val="800"/>
+            <a:pPr algn="l">
+              <a:lnSpc>
+                <a:spcPct val="105000"/>
+              </a:lnSpc>
+              <a:spcAft>
+                <a:spcPts val="200"/>
               </a:spcAft>
               <a:buNone/>
             </a:pPr>
@@ -15789,161 +15669,56 @@
                 <a:solidFill>
                   <a:srgbClr val="63637E"/>
                 </a:solidFill>
-                <a:latin typeface="Arial" panose="020B0604020202020204" pitchFamily="34" charset="0"/>
-                <a:cs typeface="Arial" panose="020B0604020202020204" pitchFamily="34" charset="0"/>
+                <a:latin typeface="Arial"/>
               </a:rPr>
-              <a:t>jina-embeddings-v2-base-code (</a:t>
+              <a:t>bge-small-en-v1.5 — switched from jina-embeddings-v2-base-code, which was too slow on CPU (2+ </a:t>
             </a:r>
             <a:r>
               <a:rPr sz="1400" b="0" dirty="0" err="1">
                 <a:solidFill>
                   <a:srgbClr val="63637E"/>
                 </a:solidFill>
-                <a:latin typeface="Arial" panose="020B0604020202020204" pitchFamily="34" charset="0"/>
-                <a:cs typeface="Arial" panose="020B0604020202020204" pitchFamily="34" charset="0"/>
+                <a:latin typeface="Arial"/>
               </a:rPr>
-              <a:t>bge</a:t>
+              <a:t>hr</a:t>
             </a:r>
             <a:r>
               <a:rPr sz="1400" b="0" dirty="0">
                 <a:solidFill>
                   <a:srgbClr val="63637E"/>
                 </a:solidFill>
-                <a:latin typeface="Arial" panose="020B0604020202020204" pitchFamily="34" charset="0"/>
-                <a:cs typeface="Arial" panose="020B0604020202020204" pitchFamily="34" charset="0"/>
+                <a:latin typeface="Arial"/>
               </a:rPr>
-              <a:t>-small-</a:t>
+              <a:t> for a full eval pass)</a:t>
             </a:r>
-            <a:r>
-              <a:rPr sz="1400" b="0" dirty="0" err="1">
-                <a:solidFill>
-                  <a:srgbClr val="63637E"/>
-                </a:solidFill>
-                <a:latin typeface="Arial" panose="020B0604020202020204" pitchFamily="34" charset="0"/>
-                <a:cs typeface="Arial" panose="020B0604020202020204" pitchFamily="34" charset="0"/>
-              </a:rPr>
-              <a:t>en</a:t>
-            </a:r>
-            <a:r>
-              <a:rPr sz="1400" b="0" dirty="0">
-                <a:solidFill>
-                  <a:srgbClr val="63637E"/>
-                </a:solidFill>
-                <a:latin typeface="Arial" panose="020B0604020202020204" pitchFamily="34" charset="0"/>
-                <a:cs typeface="Arial" panose="020B0604020202020204" pitchFamily="34" charset="0"/>
-              </a:rPr>
-              <a:t> fallback) — cod</a:t>
-            </a:r>
-            <a:r>
-              <a:rPr lang="en-IN" sz="1400" b="0" dirty="0">
-                <a:solidFill>
-                  <a:srgbClr val="63637E"/>
-                </a:solidFill>
-                <a:latin typeface="Arial" panose="020B0604020202020204" pitchFamily="34" charset="0"/>
-                <a:cs typeface="Arial" panose="020B0604020202020204" pitchFamily="34" charset="0"/>
-              </a:rPr>
-              <a:t>e</a:t>
-            </a:r>
-            <a:endParaRPr lang="en-US" sz="1400" b="0" dirty="0">
-              <a:solidFill>
-                <a:srgbClr val="63637E"/>
-              </a:solidFill>
-              <a:latin typeface="Arial" panose="020B0604020202020204" pitchFamily="34" charset="0"/>
-              <a:cs typeface="Arial" panose="020B0604020202020204" pitchFamily="34" charset="0"/>
-            </a:endParaRPr>
-          </a:p>
-          <a:p>
-            <a:pPr indent="0">
-              <a:lnSpc>
-                <a:spcPct val="100000"/>
-              </a:lnSpc>
-              <a:spcBef>
-                <a:spcPts val="0"/>
-              </a:spcBef>
-              <a:spcAft>
-                <a:spcPts val="800"/>
+          </a:p>
+          <a:p>
+            <a:pPr algn="l">
+              <a:lnSpc>
+                <a:spcPct val="105000"/>
+              </a:lnSpc>
+              <a:spcAft>
+                <a:spcPts val="200"/>
               </a:spcAft>
               <a:buNone/>
             </a:pPr>
             <a:r>
-              <a:rPr lang="en-US" sz="1400" b="0" dirty="0">
-                <a:solidFill>
-                  <a:srgbClr val="63637E"/>
-                </a:solidFill>
-                <a:latin typeface="Arial" panose="020B0604020202020204" pitchFamily="34" charset="0"/>
-                <a:cs typeface="Arial" panose="020B0604020202020204" pitchFamily="34" charset="0"/>
+              <a:rPr sz="1600" b="1" dirty="0">
+                <a:solidFill>
+                  <a:srgbClr val="14142B"/>
+                </a:solidFill>
+                <a:latin typeface="Arial"/>
               </a:rPr>
-              <a:t>aware embeddings outperform general text embeddings on code</a:t>
+              <a:t>▸ Sparse retrieval</a:t>
             </a:r>
           </a:p>
           <a:p>
-            <a:pPr indent="0">
-              <a:lnSpc>
-                <a:spcPct val="100000"/>
-              </a:lnSpc>
-              <a:spcBef>
-                <a:spcPts val="0"/>
-              </a:spcBef>
-              <a:spcAft>
-                <a:spcPts val="800"/>
-              </a:spcAft>
-              <a:buNone/>
-            </a:pPr>
-            <a:r>
-              <a:rPr lang="en-US" sz="1400" b="0" dirty="0">
-                <a:solidFill>
-                  <a:srgbClr val="63637E"/>
-                </a:solidFill>
-                <a:latin typeface="Arial" panose="020B0604020202020204" pitchFamily="34" charset="0"/>
-                <a:cs typeface="Arial" panose="020B0604020202020204" pitchFamily="34" charset="0"/>
-              </a:rPr>
-              <a:t>retrieval</a:t>
-            </a:r>
-          </a:p>
-          <a:p>
-            <a:pPr indent="0">
-              <a:lnSpc>
-                <a:spcPct val="100000"/>
-              </a:lnSpc>
-              <a:spcBef>
-                <a:spcPts val="0"/>
-              </a:spcBef>
-              <a:spcAft>
-                <a:spcPts val="800"/>
-              </a:spcAft>
-              <a:buNone/>
-            </a:pPr>
-            <a:r>
-              <a:rPr lang="en-IN" sz="1600" b="1" dirty="0">
-                <a:solidFill>
-                  <a:srgbClr val="14142B"/>
-                </a:solidFill>
-                <a:latin typeface="Arial" panose="020B0604020202020204" pitchFamily="34" charset="0"/>
-                <a:cs typeface="Arial" panose="020B0604020202020204" pitchFamily="34" charset="0"/>
-              </a:rPr>
-              <a:t>▸</a:t>
-            </a:r>
-            <a:r>
-              <a:rPr lang="en-US" sz="1600" b="1" dirty="0">
-                <a:solidFill>
-                  <a:srgbClr val="14142B"/>
-                </a:solidFill>
-                <a:latin typeface="Arial" panose="020B0604020202020204" pitchFamily="34" charset="0"/>
-                <a:cs typeface="Arial" panose="020B0604020202020204" pitchFamily="34" charset="0"/>
-              </a:rPr>
-              <a:t> Sparse retrieval</a:t>
-            </a:r>
-          </a:p>
-          <a:p>
-            <a:pPr indent="0">
-              <a:lnSpc>
-                <a:spcPct val="100000"/>
-              </a:lnSpc>
-              <a:spcBef>
-                <a:spcPts val="0"/>
-              </a:spcBef>
-              <a:spcAft>
-                <a:spcPts val="800"/>
+            <a:pPr algn="l">
+              <a:lnSpc>
+                <a:spcPct val="105000"/>
+              </a:lnSpc>
+              <a:spcAft>
+                <a:spcPts val="200"/>
               </a:spcAft>
               <a:buNone/>
             </a:pPr>
@@ -15952,29 +15727,38 @@
                 <a:solidFill>
                   <a:srgbClr val="63637E"/>
                 </a:solidFill>
-                <a:latin typeface="Arial" panose="020B0604020202020204" pitchFamily="34" charset="0"/>
-                <a:cs typeface="Arial" panose="020B0604020202020204" pitchFamily="34" charset="0"/>
+                <a:latin typeface="Arial"/>
               </a:rPr>
-              <a:t>BM25, code-aware tokenization — catches exact</a:t>
+              <a:t>Custom fast BM25, precomputed inverted index — full query set in ~5s vs. hours for naive rank_bm25 on long queries</a:t>
             </a:r>
-            <a:endParaRPr lang="en-US" sz="1400" b="0" dirty="0">
-              <a:solidFill>
-                <a:srgbClr val="63637E"/>
-              </a:solidFill>
-              <a:latin typeface="Arial" panose="020B0604020202020204" pitchFamily="34" charset="0"/>
-              <a:cs typeface="Arial" panose="020B0604020202020204" pitchFamily="34" charset="0"/>
-            </a:endParaRPr>
-          </a:p>
-          <a:p>
-            <a:pPr indent="0">
-              <a:lnSpc>
-                <a:spcPct val="100000"/>
-              </a:lnSpc>
-              <a:spcBef>
-                <a:spcPts val="0"/>
-              </a:spcBef>
-              <a:spcAft>
-                <a:spcPts val="800"/>
+          </a:p>
+          <a:p>
+            <a:pPr algn="l">
+              <a:lnSpc>
+                <a:spcPct val="105000"/>
+              </a:lnSpc>
+              <a:spcAft>
+                <a:spcPts val="200"/>
+              </a:spcAft>
+              <a:buNone/>
+            </a:pPr>
+            <a:r>
+              <a:rPr sz="1600" b="1" dirty="0">
+                <a:solidFill>
+                  <a:srgbClr val="14142B"/>
+                </a:solidFill>
+                <a:latin typeface="Arial"/>
+              </a:rPr>
+              <a:t>▸ Fusion</a:t>
+            </a:r>
+          </a:p>
+          <a:p>
+            <a:pPr algn="l">
+              <a:lnSpc>
+                <a:spcPct val="105000"/>
+              </a:lnSpc>
+              <a:spcAft>
+                <a:spcPts val="200"/>
               </a:spcAft>
               <a:buNone/>
             </a:pPr>
@@ -15983,22 +15767,18 @@
                 <a:solidFill>
                   <a:srgbClr val="63637E"/>
                 </a:solidFill>
-                <a:latin typeface="Arial" panose="020B0604020202020204" pitchFamily="34" charset="0"/>
-                <a:cs typeface="Arial" panose="020B0604020202020204" pitchFamily="34" charset="0"/>
+                <a:latin typeface="Arial"/>
               </a:rPr>
-              <a:t>identifier/keyword matches dense embeddings miss</a:t>
+              <a:t>Weighted Reciprocal Rank Fusion, hand-rolled (BM25 weight 0.3, dense 1.0) — this is the shipped pipeline, NDCG@10 0.0597</a:t>
             </a:r>
           </a:p>
           <a:p>
-            <a:pPr indent="0">
-              <a:lnSpc>
-                <a:spcPct val="100000"/>
-              </a:lnSpc>
-              <a:spcBef>
-                <a:spcPts val="0"/>
-              </a:spcBef>
-              <a:spcAft>
-                <a:spcPts val="800"/>
+            <a:pPr algn="l">
+              <a:lnSpc>
+                <a:spcPct val="105000"/>
+              </a:lnSpc>
+              <a:spcAft>
+                <a:spcPts val="200"/>
               </a:spcAft>
               <a:buNone/>
             </a:pPr>
@@ -16007,87 +15787,7 @@
                 <a:solidFill>
                   <a:srgbClr val="14142B"/>
                 </a:solidFill>
-                <a:latin typeface="Arial" panose="020B0604020202020204" pitchFamily="34" charset="0"/>
-                <a:cs typeface="Arial" panose="020B0604020202020204" pitchFamily="34" charset="0"/>
-              </a:rPr>
-              <a:t>▸ Fusion</a:t>
-            </a:r>
-          </a:p>
-          <a:p>
-            <a:pPr indent="0">
-              <a:lnSpc>
-                <a:spcPct val="100000"/>
-              </a:lnSpc>
-              <a:spcBef>
-                <a:spcPts val="0"/>
-              </a:spcBef>
-              <a:spcAft>
-                <a:spcPts val="800"/>
-              </a:spcAft>
-              <a:buNone/>
-            </a:pPr>
-            <a:r>
-              <a:rPr sz="1400" b="0" dirty="0">
-                <a:solidFill>
-                  <a:srgbClr val="63637E"/>
-                </a:solidFill>
-                <a:latin typeface="Arial" panose="020B0604020202020204" pitchFamily="34" charset="0"/>
-                <a:cs typeface="Arial" panose="020B0604020202020204" pitchFamily="34" charset="0"/>
-              </a:rPr>
-              <a:t>Reciprocal Rank Fusion, hand-rolled — combines dense + sparse</a:t>
-            </a:r>
-            <a:endParaRPr lang="en-US" sz="1400" b="0" dirty="0">
-              <a:solidFill>
-                <a:srgbClr val="63637E"/>
-              </a:solidFill>
-              <a:latin typeface="Arial" panose="020B0604020202020204" pitchFamily="34" charset="0"/>
-              <a:cs typeface="Arial" panose="020B0604020202020204" pitchFamily="34" charset="0"/>
-            </a:endParaRPr>
-          </a:p>
-          <a:p>
-            <a:pPr indent="0">
-              <a:lnSpc>
-                <a:spcPct val="100000"/>
-              </a:lnSpc>
-              <a:spcBef>
-                <a:spcPts val="0"/>
-              </a:spcBef>
-              <a:spcAft>
-                <a:spcPts val="800"/>
-              </a:spcAft>
-              <a:buNone/>
-            </a:pPr>
-            <a:r>
-              <a:rPr sz="1400" b="0" dirty="0">
-                <a:solidFill>
-                  <a:srgbClr val="63637E"/>
-                </a:solidFill>
-                <a:latin typeface="Arial" panose="020B0604020202020204" pitchFamily="34" charset="0"/>
-                <a:cs typeface="Arial" panose="020B0604020202020204" pitchFamily="34" charset="0"/>
-              </a:rPr>
-              <a:t>ranked lists without extra dependencies</a:t>
-            </a:r>
-          </a:p>
-          <a:p>
-            <a:pPr indent="0">
-              <a:lnSpc>
-                <a:spcPct val="100000"/>
-              </a:lnSpc>
-              <a:spcBef>
-                <a:spcPts val="0"/>
-              </a:spcBef>
-              <a:spcAft>
-                <a:spcPts val="800"/>
-              </a:spcAft>
-              <a:buNone/>
-            </a:pPr>
-            <a:r>
-              <a:rPr sz="1600" b="1" dirty="0">
-                <a:solidFill>
-                  <a:srgbClr val="14142B"/>
-                </a:solidFill>
-                <a:latin typeface="Arial" panose="020B0604020202020204" pitchFamily="34" charset="0"/>
-                <a:cs typeface="Arial" panose="020B0604020202020204" pitchFamily="34" charset="0"/>
+                <a:latin typeface="Arial"/>
               </a:rPr>
               <a:t>▸ </a:t>
             </a:r>
@@ -16096,8 +15796,7 @@
                 <a:solidFill>
                   <a:srgbClr val="14142B"/>
                 </a:solidFill>
-                <a:latin typeface="Arial" panose="020B0604020202020204" pitchFamily="34" charset="0"/>
-                <a:cs typeface="Arial" panose="020B0604020202020204" pitchFamily="34" charset="0"/>
+                <a:latin typeface="Arial"/>
               </a:rPr>
               <a:t>Reranker</a:t>
             </a:r>
@@ -16105,30 +15804,34 @@
               <a:solidFill>
                 <a:srgbClr val="14142B"/>
               </a:solidFill>
-              <a:latin typeface="Arial" panose="020B0604020202020204" pitchFamily="34" charset="0"/>
-              <a:cs typeface="Arial" panose="020B0604020202020204" pitchFamily="34" charset="0"/>
+              <a:latin typeface="Arial"/>
             </a:endParaRPr>
           </a:p>
           <a:p>
-            <a:pPr indent="0">
-              <a:lnSpc>
-                <a:spcPct val="100000"/>
-              </a:lnSpc>
-              <a:spcBef>
-                <a:spcPts val="0"/>
-              </a:spcBef>
-              <a:spcAft>
-                <a:spcPts val="800"/>
+            <a:pPr algn="l">
+              <a:lnSpc>
+                <a:spcPct val="105000"/>
+              </a:lnSpc>
+              <a:spcAft>
+                <a:spcPts val="200"/>
               </a:spcAft>
               <a:buNone/>
             </a:pPr>
             <a:r>
+              <a:rPr sz="1400" b="0" dirty="0">
+                <a:solidFill>
+                  <a:srgbClr val="63637E"/>
+                </a:solidFill>
+                <a:latin typeface="Arial"/>
+              </a:rPr>
+              <a:t>None in the shipped pipeline — </a:t>
+            </a:r>
+            <a:r>
               <a:rPr sz="1400" b="0" dirty="0" err="1">
                 <a:solidFill>
                   <a:srgbClr val="63637E"/>
                 </a:solidFill>
-                <a:latin typeface="Arial" panose="020B0604020202020204" pitchFamily="34" charset="0"/>
-                <a:cs typeface="Arial" panose="020B0604020202020204" pitchFamily="34" charset="0"/>
+                <a:latin typeface="Arial"/>
               </a:rPr>
               <a:t>bge</a:t>
             </a:r>
@@ -16137,8 +15840,7 @@
                 <a:solidFill>
                   <a:srgbClr val="63637E"/>
                 </a:solidFill>
-                <a:latin typeface="Arial" panose="020B0604020202020204" pitchFamily="34" charset="0"/>
-                <a:cs typeface="Arial" panose="020B0604020202020204" pitchFamily="34" charset="0"/>
+                <a:latin typeface="Arial"/>
               </a:rPr>
               <a:t>-</a:t>
             </a:r>
@@ -16147,8 +15849,7 @@
                 <a:solidFill>
                   <a:srgbClr val="63637E"/>
                 </a:solidFill>
-                <a:latin typeface="Arial" panose="020B0604020202020204" pitchFamily="34" charset="0"/>
-                <a:cs typeface="Arial" panose="020B0604020202020204" pitchFamily="34" charset="0"/>
+                <a:latin typeface="Arial"/>
               </a:rPr>
               <a:t>reranker</a:t>
             </a:r>
@@ -16157,91 +15858,73 @@
                 <a:solidFill>
                   <a:srgbClr val="63637E"/>
                 </a:solidFill>
-                <a:latin typeface="Arial" panose="020B0604020202020204" pitchFamily="34" charset="0"/>
-                <a:cs typeface="Arial" panose="020B0604020202020204" pitchFamily="34" charset="0"/>
+                <a:latin typeface="Arial"/>
               </a:rPr>
-              <a:t>-base cross-encoder — largest single lever on</a:t>
-            </a:r>
-            <a:endParaRPr lang="en-US" sz="1400" b="0" dirty="0">
-              <a:solidFill>
-                <a:srgbClr val="63637E"/>
-              </a:solidFill>
-              <a:latin typeface="Arial" panose="020B0604020202020204" pitchFamily="34" charset="0"/>
-              <a:cs typeface="Arial" panose="020B0604020202020204" pitchFamily="34" charset="0"/>
-            </a:endParaRPr>
-          </a:p>
-          <a:p>
-            <a:pPr indent="0">
-              <a:lnSpc>
-                <a:spcPct val="100000"/>
-              </a:lnSpc>
-              <a:spcBef>
-                <a:spcPts val="0"/>
-              </a:spcBef>
-              <a:spcAft>
-                <a:spcPts val="800"/>
-              </a:spcAft>
-              <a:buNone/>
-            </a:pPr>
-            <a:r>
-              <a:rPr sz="1400" b="0" dirty="0">
-                <a:solidFill>
-                  <a:srgbClr val="63637E"/>
-                </a:solidFill>
-                <a:latin typeface="Arial" panose="020B0604020202020204" pitchFamily="34" charset="0"/>
-                <a:cs typeface="Arial" panose="020B0604020202020204" pitchFamily="34" charset="0"/>
-              </a:rPr>
-              <a:t>NDCG@10; CPU-fast over a small candidate set</a:t>
+              <a:t>-base (too slow, ~11.6h/full split) and MiniLM-L6-v2 (fast enough, but regressed NDCG@10 to 0.0528) were both evaluated and rejected</a:t>
             </a:r>
           </a:p>
         </p:txBody>
       </p:sp>
       <p:sp>
         <p:nvSpPr>
-          <p:cNvPr id="127" name="TextBox 126"/>
-          <p:cNvSpPr txBox="1"/>
+          <p:cNvPr id="164" name="TextBox 126"/>
+          <p:cNvSpPr txBox="1">
+            <a:spLocks noGrp="1"/>
+          </p:cNvSpPr>
           <p:nvPr/>
         </p:nvSpPr>
         <p:spPr>
           <a:xfrm>
-            <a:off x="6250000" y="1350000"/>
-            <a:ext cx="5100000" cy="5400000"/>
+            <a:off x="6250000" y="1260000"/>
+            <a:ext cx="5100000" cy="5578000"/>
           </a:xfrm>
           <a:prstGeom prst="rect">
             <a:avLst/>
           </a:prstGeom>
           <a:noFill/>
+          <a:ln>
+            <a:noFill/>
+          </a:ln>
         </p:spPr>
         <p:txBody>
-          <a:bodyPr wrap="square">
+          <a:bodyPr spcFirstLastPara="1" wrap="square" lIns="91425" tIns="45700" rIns="91425" bIns="45700" anchor="t" anchorCtr="0">
             <a:noAutofit/>
           </a:bodyPr>
           <a:lstStyle/>
           <a:p>
-            <a:pPr>
-              <a:lnSpc>
-                <a:spcPct val="115000"/>
-              </a:lnSpc>
-              <a:spcAft>
-                <a:spcPts val="800"/>
-              </a:spcAft>
+            <a:pPr algn="l">
+              <a:lnSpc>
+                <a:spcPct val="105000"/>
+              </a:lnSpc>
+              <a:spcBef>
+                <a:spcPts val="0"/>
+              </a:spcBef>
+              <a:spcAft>
+                <a:spcPts val="200"/>
+              </a:spcAft>
+              <a:buNone/>
             </a:pPr>
             <a:r>
               <a:rPr sz="1600" b="1" dirty="0">
                 <a:solidFill>
                   <a:srgbClr val="14142B"/>
                 </a:solidFill>
+                <a:latin typeface="Arial"/>
               </a:rPr>
               <a:t>▸ Vector store</a:t>
             </a:r>
-          </a:p>
-          <a:p>
-            <a:pPr>
-              <a:lnSpc>
-                <a:spcPct val="115000"/>
-              </a:lnSpc>
-              <a:spcAft>
-                <a:spcPts val="800"/>
+            <a:endParaRPr dirty="0">
+              <a:latin typeface="Arial" panose="020B0604020202020204" pitchFamily="34" charset="0"/>
+              <a:cs typeface="Arial" panose="020B0604020202020204" pitchFamily="34" charset="0"/>
+            </a:endParaRPr>
+          </a:p>
+          <a:p>
+            <a:pPr algn="l">
+              <a:lnSpc>
+                <a:spcPct val="105000"/>
+              </a:lnSpc>
+              <a:spcAft>
+                <a:spcPts val="200"/>
               </a:spcAft>
             </a:pPr>
             <a:r>
@@ -16249,6 +15932,7 @@
                 <a:solidFill>
                   <a:srgbClr val="63637E"/>
                 </a:solidFill>
+                <a:latin typeface="Arial"/>
               </a:rPr>
               <a:t>FAISS, </a:t>
             </a:r>
@@ -16257,6 +15941,7 @@
                 <a:solidFill>
                   <a:srgbClr val="63637E"/>
                 </a:solidFill>
+                <a:latin typeface="Arial"/>
               </a:rPr>
               <a:t>IndexIDMap</a:t>
             </a:r>
@@ -16265,17 +15950,18 @@
                 <a:solidFill>
                   <a:srgbClr val="63637E"/>
                 </a:solidFill>
+                <a:latin typeface="Arial"/>
               </a:rPr>
               <a:t> — local, no server dependency; supports incremental add/remove for P1 versioning</a:t>
             </a:r>
           </a:p>
           <a:p>
-            <a:pPr>
-              <a:lnSpc>
-                <a:spcPct val="115000"/>
-              </a:lnSpc>
-              <a:spcAft>
-                <a:spcPts val="800"/>
+            <a:pPr algn="l">
+              <a:lnSpc>
+                <a:spcPct val="105000"/>
+              </a:lnSpc>
+              <a:spcAft>
+                <a:spcPts val="200"/>
               </a:spcAft>
             </a:pPr>
             <a:r>
@@ -16283,17 +15969,18 @@
                 <a:solidFill>
                   <a:srgbClr val="14142B"/>
                 </a:solidFill>
+                <a:latin typeface="Arial"/>
               </a:rPr>
               <a:t>▸ Code parsing</a:t>
             </a:r>
           </a:p>
           <a:p>
-            <a:pPr>
-              <a:lnSpc>
-                <a:spcPct val="115000"/>
-              </a:lnSpc>
-              <a:spcAft>
-                <a:spcPts val="800"/>
+            <a:pPr algn="l">
+              <a:lnSpc>
+                <a:spcPct val="105000"/>
+              </a:lnSpc>
+              <a:spcAft>
+                <a:spcPts val="200"/>
               </a:spcAft>
             </a:pPr>
             <a:r>
@@ -16301,17 +15988,18 @@
                 <a:solidFill>
                   <a:srgbClr val="63637E"/>
                 </a:solidFill>
+                <a:latin typeface="Arial"/>
               </a:rPr>
-              <a:t>tree-sitter — function/block-level snippet extraction + call-graph construction for structural queries</a:t>
+              <a:t>tree-sitter, JS + Python grammars — function/block-level extraction, call-graph queries, and content-hash snippet identity for versioning</a:t>
             </a:r>
           </a:p>
           <a:p>
-            <a:pPr>
-              <a:lnSpc>
-                <a:spcPct val="115000"/>
-              </a:lnSpc>
-              <a:spcAft>
-                <a:spcPts val="800"/>
+            <a:pPr algn="l">
+              <a:lnSpc>
+                <a:spcPct val="105000"/>
+              </a:lnSpc>
+              <a:spcAft>
+                <a:spcPts val="200"/>
               </a:spcAft>
             </a:pPr>
             <a:r>
@@ -16319,17 +16007,18 @@
                 <a:solidFill>
                   <a:srgbClr val="14142B"/>
                 </a:solidFill>
+                <a:latin typeface="Arial"/>
               </a:rPr>
               <a:t>▸ Metadata store</a:t>
             </a:r>
           </a:p>
           <a:p>
-            <a:pPr>
-              <a:lnSpc>
-                <a:spcPct val="115000"/>
-              </a:lnSpc>
-              <a:spcAft>
-                <a:spcPts val="800"/>
+            <a:pPr algn="l">
+              <a:lnSpc>
+                <a:spcPct val="105000"/>
+              </a:lnSpc>
+              <a:spcAft>
+                <a:spcPts val="200"/>
               </a:spcAft>
             </a:pPr>
             <a:r>
@@ -16337,17 +16026,18 @@
                 <a:solidFill>
                   <a:srgbClr val="63637E"/>
                 </a:solidFill>
+                <a:latin typeface="Arial"/>
               </a:rPr>
-              <a:t>SQLite — lightweight snippet/version bookkeeping, no server needed</a:t>
+              <a:t>SQLite — snippet/version bookkeeping, lineage chains (union-find over edit history), no server needed</a:t>
             </a:r>
           </a:p>
           <a:p>
-            <a:pPr>
-              <a:lnSpc>
-                <a:spcPct val="115000"/>
-              </a:lnSpc>
-              <a:spcAft>
-                <a:spcPts val="800"/>
+            <a:pPr algn="l">
+              <a:lnSpc>
+                <a:spcPct val="105000"/>
+              </a:lnSpc>
+              <a:spcAft>
+                <a:spcPts val="200"/>
               </a:spcAft>
             </a:pPr>
             <a:r>
@@ -16355,17 +16045,18 @@
                 <a:solidFill>
                   <a:srgbClr val="14142B"/>
                 </a:solidFill>
+                <a:latin typeface="Arial"/>
               </a:rPr>
               <a:t>▸ Evaluation</a:t>
             </a:r>
           </a:p>
           <a:p>
-            <a:pPr>
-              <a:lnSpc>
-                <a:spcPct val="115000"/>
-              </a:lnSpc>
-              <a:spcAft>
-                <a:spcPts val="800"/>
+            <a:pPr algn="l">
+              <a:lnSpc>
+                <a:spcPct val="105000"/>
+              </a:lnSpc>
+              <a:spcAft>
+                <a:spcPts val="200"/>
               </a:spcAft>
             </a:pPr>
             <a:r>
@@ -16373,6 +16064,7 @@
                 <a:solidFill>
                   <a:srgbClr val="63637E"/>
                 </a:solidFill>
+                <a:latin typeface="Arial"/>
               </a:rPr>
               <a:t>MTEB library, </a:t>
             </a:r>
@@ -16381,6 +16073,7 @@
                 <a:solidFill>
                   <a:srgbClr val="63637E"/>
                 </a:solidFill>
+                <a:latin typeface="Arial"/>
               </a:rPr>
               <a:t>AppsRetrieval</a:t>
             </a:r>
@@ -16389,17 +16082,18 @@
                 <a:solidFill>
                   <a:srgbClr val="63637E"/>
                 </a:solidFill>
+                <a:latin typeface="Arial"/>
               </a:rPr>
-              <a:t> task — required submission format; used for self-evaluation and the official JSON output</a:t>
+              <a:t> task — official submission format; cold-clone reproduced bit-identical scores across two dependency versions</a:t>
             </a:r>
           </a:p>
           <a:p>
-            <a:pPr>
-              <a:lnSpc>
-                <a:spcPct val="115000"/>
-              </a:lnSpc>
-              <a:spcAft>
-                <a:spcPts val="800"/>
+            <a:pPr algn="l">
+              <a:lnSpc>
+                <a:spcPct val="105000"/>
+              </a:lnSpc>
+              <a:spcAft>
+                <a:spcPts val="200"/>
               </a:spcAft>
             </a:pPr>
             <a:r>
@@ -16407,17 +16101,18 @@
                 <a:solidFill>
                   <a:srgbClr val="14142B"/>
                 </a:solidFill>
+                <a:latin typeface="Arial"/>
               </a:rPr>
               <a:t>▸ Orchestration</a:t>
             </a:r>
           </a:p>
           <a:p>
-            <a:pPr>
-              <a:lnSpc>
-                <a:spcPct val="115000"/>
-              </a:lnSpc>
-              <a:spcAft>
-                <a:spcPts val="800"/>
+            <a:pPr algn="l">
+              <a:lnSpc>
+                <a:spcPct val="105000"/>
+              </a:lnSpc>
+              <a:spcAft>
+                <a:spcPts val="200"/>
               </a:spcAft>
             </a:pPr>
             <a:r>
@@ -16425,6 +16120,7 @@
                 <a:solidFill>
                   <a:srgbClr val="63637E"/>
                 </a:solidFill>
+                <a:latin typeface="Arial"/>
               </a:rPr>
               <a:t>Plain Python, no heavy framework — kept </a:t>
             </a:r>
@@ -16433,6 +16129,7 @@
                 <a:solidFill>
                   <a:srgbClr val="63637E"/>
                 </a:solidFill>
+                <a:latin typeface="Arial"/>
               </a:rPr>
               <a:t>debuggable</a:t>
             </a:r>
@@ -16441,8 +16138,9 @@
                 <a:solidFill>
                   <a:srgbClr val="63637E"/>
                 </a:solidFill>
+                <a:latin typeface="Arial"/>
               </a:rPr>
-              <a:t> and fast; framework overhead added no grading value here</a:t>
+              <a:t> and fast; no fallback-model indirection (removed as dead code)</a:t>
             </a:r>
           </a:p>
         </p:txBody>
@@ -16519,7 +16217,7 @@
               <a:buNone/>
             </a:pPr>
             <a:r>
-              <a:rPr lang="en-US" sz="4400" b="1">
+              <a:rPr lang="en-US" sz="4000" b="1">
                 <a:solidFill>
                   <a:srgbClr val="704EA6"/>
                 </a:solidFill>
@@ -16580,7 +16278,7 @@
               <a:buSzPct val="140000"/>
             </a:pPr>
             <a:r>
-              <a:rPr sz="1800" b="1" dirty="0">
+              <a:rPr sz="1600" b="1" dirty="0">
                 <a:solidFill>
                   <a:srgbClr val="6D28D9"/>
                 </a:solidFill>
@@ -16599,7 +16297,7 @@
               </a:spcAft>
             </a:pPr>
             <a:r>
-              <a:rPr sz="1600" b="0" dirty="0">
+              <a:rPr sz="1400" b="0" dirty="0">
                 <a:solidFill>
                   <a:srgbClr val="63637E"/>
                 </a:solidFill>
@@ -16617,7 +16315,7 @@
               </a:spcAft>
             </a:pPr>
             <a:r>
-              <a:rPr sz="1800" b="1" dirty="0">
+              <a:rPr sz="1600" b="1" dirty="0">
                 <a:solidFill>
                   <a:srgbClr val="6D28D9"/>
                 </a:solidFill>
@@ -16635,7 +16333,7 @@
               </a:spcAft>
             </a:pPr>
             <a:r>
-              <a:rPr sz="1600" b="0" dirty="0">
+              <a:rPr sz="1400" b="0" dirty="0">
                 <a:solidFill>
                   <a:srgbClr val="63637E"/>
                 </a:solidFill>
@@ -16653,7 +16351,7 @@
               </a:spcAft>
             </a:pPr>
             <a:r>
-              <a:rPr sz="1600" b="0" dirty="0">
+              <a:rPr sz="1400" b="0" dirty="0">
                 <a:solidFill>
                   <a:srgbClr val="63637E"/>
                 </a:solidFill>
@@ -16671,7 +16369,7 @@
               </a:spcAft>
             </a:pPr>
             <a:r>
-              <a:rPr sz="1800" b="1" dirty="0">
+              <a:rPr sz="1600" b="1" dirty="0">
                 <a:solidFill>
                   <a:srgbClr val="6D28D9"/>
                 </a:solidFill>
@@ -16689,7 +16387,7 @@
               </a:spcAft>
             </a:pPr>
             <a:r>
-              <a:rPr sz="1600" b="0" dirty="0">
+              <a:rPr sz="1400" b="0" dirty="0">
                 <a:solidFill>
                   <a:srgbClr val="63637E"/>
                 </a:solidFill>
@@ -16771,7 +16469,7 @@
               <a:buNone/>
             </a:pPr>
             <a:r>
-              <a:rPr lang="en-US" sz="3200" b="1" dirty="0">
+              <a:rPr lang="en-US" sz="4000" b="1" dirty="0">
                 <a:solidFill>
                   <a:srgbClr val="704EA6"/>
                 </a:solidFill>
@@ -16802,8 +16500,8 @@
         </p:nvSpPr>
         <p:spPr>
           <a:xfrm>
-            <a:off x="838200" y="1300000"/>
-            <a:ext cx="10515600" cy="2250000"/>
+            <a:off x="838200" y="1250000"/>
+            <a:ext cx="10515600" cy="2450000"/>
           </a:xfrm>
           <a:prstGeom prst="rect">
             <a:avLst/>
@@ -16819,162 +16517,101 @@
           </a:bodyPr>
           <a:lstStyle/>
           <a:p>
-            <a:pPr marL="463550" indent="-285750">
-              <a:lnSpc>
-                <a:spcPct val="115000"/>
-              </a:lnSpc>
-              <a:spcBef>
-                <a:spcPts val="0"/>
-              </a:spcBef>
-              <a:spcAft>
-                <a:spcPts val="600"/>
-              </a:spcAft>
-              <a:buSzPct val="140000"/>
+            <a:pPr algn="l">
+              <a:lnSpc>
+                <a:spcPct val="105000"/>
+              </a:lnSpc>
+              <a:spcBef>
+                <a:spcPts val="0"/>
+              </a:spcBef>
+              <a:spcAft>
+                <a:spcPts val="200"/>
+              </a:spcAft>
             </a:pPr>
             <a:r>
-              <a:rPr lang="en-IN" sz="1400" b="1" dirty="0">
-                <a:solidFill>
-                  <a:schemeClr val="tx1"/>
-                </a:solidFill>
-                <a:latin typeface="+mj-lt"/>
+              <a:rPr sz="1500" b="1">
+                <a:solidFill>
+                  <a:srgbClr val="6D28D9"/>
+                </a:solidFill>
+                <a:latin typeface="Arial"/>
               </a:rPr>
               <a:t>Innovation: content-addressed, diff-driven indexing</a:t>
             </a:r>
-            <a:r>
-              <a:rPr lang="en-IN" sz="1400" dirty="0">
-                <a:solidFill>
-                  <a:schemeClr val="tx1"/>
-                </a:solidFill>
-                <a:latin typeface="+mj-lt"/>
-              </a:rPr>
-              <a:t>  </a:t>
-            </a:r>
-          </a:p>
-          <a:p>
-            <a:pPr marL="635000" lvl="1" indent="0">
-              <a:lnSpc>
-                <a:spcPct val="115000"/>
-              </a:lnSpc>
-              <a:spcBef>
-                <a:spcPts val="0"/>
-              </a:spcBef>
-              <a:spcAft>
-                <a:spcPts val="600"/>
-              </a:spcAft>
-              <a:buSzPct val="140000"/>
-              <a:buNone/>
+          </a:p>
+          <a:p>
+            <a:pPr lvl="1" algn="l">
+              <a:lnSpc>
+                <a:spcPct val="105000"/>
+              </a:lnSpc>
+              <a:spcAft>
+                <a:spcPts val="200"/>
+              </a:spcAft>
             </a:pPr>
             <a:r>
-              <a:rPr sz="1400" b="0" dirty="0" err="1">
-                <a:solidFill>
-                  <a:schemeClr val="tx1"/>
-                </a:solidFill>
-                <a:latin typeface="+mj-lt"/>
+              <a:rPr sz="1200" b="0">
+                <a:solidFill>
+                  <a:srgbClr val="63637E"/>
+                </a:solidFill>
+                <a:latin typeface="Arial"/>
               </a:rPr>
-              <a:t>snippet_id</a:t>
+              <a:t>snippet_id = hash(AST-structural code) — unchanged functions keep their ID across versions; only real diffs are re-embedded. One mechanism drives both P1 reindexing and Bonus lineage grouping.</a:t>
             </a:r>
-            <a:r>
-              <a:rPr sz="1400" b="0" dirty="0">
-                <a:solidFill>
-                  <a:schemeClr val="tx1"/>
-                </a:solidFill>
-                <a:latin typeface="+mj-lt"/>
-              </a:rPr>
-              <a:t> = hash(normalized code) — unchanged functions keep their ID across versions, so only real diffs are re-embedded. Satisfies P1's “reasonable rebuild time” bar and enables the Bonus goal via lineage-grouped ranking.</a:t>
-            </a:r>
-          </a:p>
-          <a:p>
-            <a:pPr>
-              <a:lnSpc>
-                <a:spcPct val="115000"/>
-              </a:lnSpc>
-              <a:spcAft>
-                <a:spcPts val="600"/>
-              </a:spcAft>
-              <a:buSzPct val="140000"/>
+          </a:p>
+          <a:p>
+            <a:pPr algn="l">
+              <a:lnSpc>
+                <a:spcPct val="105000"/>
+              </a:lnSpc>
+              <a:spcAft>
+                <a:spcPts val="200"/>
+              </a:spcAft>
             </a:pPr>
             <a:r>
-              <a:rPr sz="1400" b="1" dirty="0">
-                <a:solidFill>
-                  <a:schemeClr val="tx1"/>
-                </a:solidFill>
-                <a:latin typeface="+mj-lt"/>
+              <a:rPr sz="1200" b="0">
+                <a:solidFill>
+                  <a:srgbClr val="14142B"/>
+                </a:solidFill>
+                <a:latin typeface="Arial"/>
               </a:rPr>
-              <a:t>Results</a:t>
+              <a:t>Results: dense-only 0.0564 → +BM25 weighted RRF 0.0597 (shipped) → +MiniLM rerank 0.0528 (regressed, rejected). bge-reranker-base also rejected as too slow (~11.6h/full split).</a:t>
             </a:r>
-            <a:r>
-              <a:rPr sz="1400" b="0" dirty="0">
-                <a:solidFill>
-                  <a:schemeClr val="tx1"/>
-                </a:solidFill>
-                <a:latin typeface="+mj-lt"/>
-              </a:rPr>
-              <a:t>: ablation-driven, not guessed — dense-only → +BM25 fusion → +reranking, each stage measured against the same NDCG@10/MRR baseline on </a:t>
-            </a:r>
-            <a:r>
-              <a:rPr sz="1400" b="0" dirty="0" err="1">
-                <a:solidFill>
-                  <a:schemeClr val="tx1"/>
-                </a:solidFill>
-                <a:latin typeface="+mj-lt"/>
-              </a:rPr>
-              <a:t>CoIR</a:t>
-            </a:r>
-            <a:r>
-              <a:rPr sz="1400" b="0" dirty="0">
-                <a:solidFill>
-                  <a:schemeClr val="tx1"/>
-                </a:solidFill>
-                <a:latin typeface="+mj-lt"/>
-              </a:rPr>
-              <a:t> apps.</a:t>
-            </a:r>
-          </a:p>
-          <a:p>
-            <a:pPr>
-              <a:lnSpc>
-                <a:spcPct val="115000"/>
-              </a:lnSpc>
-              <a:spcAft>
-                <a:spcPts val="600"/>
-              </a:spcAft>
-              <a:buSzPct val="140000"/>
+          </a:p>
+          <a:p>
+            <a:pPr algn="l">
+              <a:lnSpc>
+                <a:spcPct val="105000"/>
+              </a:lnSpc>
+              <a:spcAft>
+                <a:spcPts val="200"/>
+              </a:spcAft>
             </a:pPr>
             <a:r>
-              <a:rPr sz="1400" b="1" dirty="0">
-                <a:solidFill>
-                  <a:schemeClr val="tx1"/>
-                </a:solidFill>
-                <a:latin typeface="+mj-lt"/>
+              <a:rPr sz="1200" b="0">
+                <a:solidFill>
+                  <a:srgbClr val="14142B"/>
+                </a:solidFill>
+                <a:latin typeface="Arial"/>
               </a:rPr>
-              <a:t>Limitations</a:t>
+              <a:t>P1: incremental reindex flat at 2–5s regardless of repo size (500–2,000 files, ≥18–67× faster than full rebuild); exactly 1 snippet re-embedded for a 1-file change.</a:t>
             </a:r>
+          </a:p>
+          <a:p>
+            <a:pPr algn="l">
+              <a:lnSpc>
+                <a:spcPct val="105000"/>
+              </a:lnSpc>
+              <a:spcAft>
+                <a:spcPts val="200"/>
+              </a:spcAft>
+            </a:pPr>
             <a:r>
-              <a:rPr sz="1400" b="0" dirty="0">
-                <a:solidFill>
-                  <a:schemeClr val="tx1"/>
-                </a:solidFill>
-                <a:latin typeface="+mj-lt"/>
+              <a:rPr sz="1200" b="0">
+                <a:solidFill>
+                  <a:srgbClr val="14142B"/>
+                </a:solidFill>
+                <a:latin typeface="Arial"/>
               </a:rPr>
-              <a:t>: </a:t>
-            </a:r>
-            <a:r>
-              <a:rPr sz="1400" b="0" dirty="0" err="1">
-                <a:solidFill>
-                  <a:schemeClr val="tx1"/>
-                </a:solidFill>
-                <a:latin typeface="+mj-lt"/>
-              </a:rPr>
-              <a:t>reranker</a:t>
-            </a:r>
-            <a:r>
-              <a:rPr sz="1400" b="0" dirty="0">
-                <a:solidFill>
-                  <a:schemeClr val="tx1"/>
-                </a:solidFill>
-                <a:latin typeface="+mj-lt"/>
-              </a:rPr>
-              <a:t> cost scales with candidate count; BM25 tokenization is a known tuning point; structural coverage is scoped to the sample codebase.</a:t>
+              <a:t>Bonus: lineage grouping removed 100% of redundant near-duplicate slots in a scale test, 0 lineages ever dropped. Limitations and caveats are in the README/reproducibility audit.</a:t>
             </a:r>
           </a:p>
         </p:txBody>
@@ -17075,7 +16712,7 @@
               <a:buNone/>
             </a:pPr>
             <a:r>
-              <a:rPr lang="en-US" sz="4400" b="1">
+              <a:rPr lang="en-US" sz="4000" b="1">
                 <a:solidFill>
                   <a:srgbClr val="704EA6"/>
                 </a:solidFill>
@@ -17107,7 +16744,7 @@
         <p:spPr>
           <a:xfrm>
             <a:off x="838200" y="1611615"/>
-            <a:ext cx="10515600" cy="4769729"/>
+            <a:ext cx="10515600" cy="5226385"/>
           </a:xfrm>
           <a:prstGeom prst="rect">
             <a:avLst/>
@@ -17123,186 +16760,195 @@
           </a:bodyPr>
           <a:lstStyle/>
           <a:p>
-            <a:pPr marL="463550" indent="-285750">
-              <a:lnSpc>
-                <a:spcPct val="115000"/>
-              </a:lnSpc>
-              <a:spcBef>
-                <a:spcPts val="0"/>
-              </a:spcBef>
-              <a:spcAft>
-                <a:spcPts val="1000"/>
-              </a:spcAft>
-              <a:buSzPct val="100000"/>
+            <a:pPr algn="l">
+              <a:lnSpc>
+                <a:spcPct val="105000"/>
+              </a:lnSpc>
+              <a:spcBef>
+                <a:spcPts val="0"/>
+              </a:spcBef>
+              <a:spcAft>
+                <a:spcPts val="300"/>
+              </a:spcAft>
             </a:pPr>
             <a:r>
-              <a:rPr sz="1700" b="1" dirty="0">
+              <a:rPr sz="1600" b="1">
                 <a:solidFill>
                   <a:srgbClr val="14142B"/>
                 </a:solidFill>
+                <a:latin typeface="Arial"/>
               </a:rPr>
               <a:t>Extend structural query coverage</a:t>
             </a:r>
             <a:endParaRPr dirty="0"/>
           </a:p>
           <a:p>
-            <a:pPr lvl="1">
-              <a:lnSpc>
-                <a:spcPct val="115000"/>
-              </a:lnSpc>
-              <a:spcAft>
-                <a:spcPts val="1000"/>
+            <a:pPr lvl="1" algn="l">
+              <a:lnSpc>
+                <a:spcPct val="105000"/>
+              </a:lnSpc>
+              <a:spcAft>
+                <a:spcPts val="300"/>
               </a:spcAft>
             </a:pPr>
             <a:r>
-              <a:rPr sz="1400" b="0" dirty="0">
+              <a:rPr sz="1400" b="0">
                 <a:solidFill>
                   <a:srgbClr val="63637E"/>
                 </a:solidFill>
+                <a:latin typeface="Arial"/>
               </a:rPr>
-              <a:t>Broader call-graph pattern support beyond the current query set</a:t>
+              <a:t>Broader call-graph pattern support; rename+edit lineage linking (currently breaks the chain by design, documented as a known limit)</a:t>
             </a:r>
           </a:p>
           <a:p>
-            <a:pPr>
-              <a:lnSpc>
-                <a:spcPct val="115000"/>
-              </a:lnSpc>
-              <a:spcAft>
-                <a:spcPts val="1000"/>
+            <a:pPr algn="l">
+              <a:lnSpc>
+                <a:spcPct val="105000"/>
+              </a:lnSpc>
+              <a:spcAft>
+                <a:spcPts val="300"/>
               </a:spcAft>
             </a:pPr>
             <a:r>
-              <a:rPr sz="1700" b="1" dirty="0">
+              <a:rPr sz="1600" b="1">
                 <a:solidFill>
                   <a:srgbClr val="14142B"/>
                 </a:solidFill>
+                <a:latin typeface="Arial"/>
               </a:rPr>
               <a:t>Move BM25 to an incrementally-updatable engine</a:t>
             </a:r>
           </a:p>
           <a:p>
-            <a:pPr lvl="1">
-              <a:lnSpc>
-                <a:spcPct val="115000"/>
-              </a:lnSpc>
-              <a:spcAft>
-                <a:spcPts val="1000"/>
+            <a:pPr lvl="1" algn="l">
+              <a:lnSpc>
+                <a:spcPct val="105000"/>
+              </a:lnSpc>
+              <a:spcAft>
+                <a:spcPts val="300"/>
               </a:spcAft>
             </a:pPr>
             <a:r>
-              <a:rPr sz="1400" b="0" dirty="0">
+              <a:rPr sz="1400" b="0">
                 <a:solidFill>
                   <a:srgbClr val="63637E"/>
                 </a:solidFill>
+                <a:latin typeface="Arial"/>
               </a:rPr>
-              <a:t>e.g. Tantivy/Whoosh, if rebuild time becomes measurable at larger corpus scale</a:t>
+              <a:t>e.g. Tantivy/Whoosh, if rebuild time becomes measurable at larger corpus scale — not needed yet (rebuild is ~1s of a 2–5s incremental update)</a:t>
             </a:r>
           </a:p>
           <a:p>
-            <a:pPr>
-              <a:lnSpc>
-                <a:spcPct val="115000"/>
-              </a:lnSpc>
-              <a:spcAft>
-                <a:spcPts val="1000"/>
+            <a:pPr algn="l">
+              <a:lnSpc>
+                <a:spcPct val="105000"/>
+              </a:lnSpc>
+              <a:spcAft>
+                <a:spcPts val="300"/>
               </a:spcAft>
             </a:pPr>
             <a:r>
-              <a:rPr sz="1700" b="1" dirty="0">
+              <a:rPr sz="1600" b="1">
                 <a:solidFill>
                   <a:srgbClr val="14142B"/>
                 </a:solidFill>
+                <a:latin typeface="Arial"/>
               </a:rPr>
-              <a:t>Multi-language support</a:t>
+              <a:t>Multi-language support beyond JS + Python</a:t>
             </a:r>
           </a:p>
           <a:p>
-            <a:pPr lvl="1">
-              <a:lnSpc>
-                <a:spcPct val="115000"/>
-              </a:lnSpc>
-              <a:spcAft>
-                <a:spcPts val="1000"/>
+            <a:pPr lvl="1" algn="l">
+              <a:lnSpc>
+                <a:spcPct val="105000"/>
+              </a:lnSpc>
+              <a:spcAft>
+                <a:spcPts val="300"/>
               </a:spcAft>
             </a:pPr>
             <a:r>
-              <a:rPr sz="1400" b="0" dirty="0">
+              <a:rPr sz="1400" b="0">
                 <a:solidFill>
                   <a:srgbClr val="63637E"/>
                 </a:solidFill>
+                <a:latin typeface="Arial"/>
               </a:rPr>
-              <a:t>Current tree-sitter/parsing layer is JS-first; extending to Python/Java is a grammar swap, not an architecture change</a:t>
+              <a:t>tree-sitter grammar swap, not an architecture change — already proven across two languages sharing one extractor interface</a:t>
             </a:r>
           </a:p>
           <a:p>
-            <a:pPr>
-              <a:lnSpc>
-                <a:spcPct val="115000"/>
-              </a:lnSpc>
-              <a:spcAft>
-                <a:spcPts val="1000"/>
+            <a:pPr algn="l">
+              <a:lnSpc>
+                <a:spcPct val="105000"/>
+              </a:lnSpc>
+              <a:spcAft>
+                <a:spcPts val="300"/>
               </a:spcAft>
             </a:pPr>
             <a:r>
-              <a:rPr sz="1700" b="1" dirty="0">
+              <a:rPr sz="1600" b="1">
                 <a:solidFill>
                   <a:srgbClr val="14142B"/>
                 </a:solidFill>
+                <a:latin typeface="Arial"/>
               </a:rPr>
-              <a:t>Query expansion via lightweight LLM paraphrasing</a:t>
+              <a:t>Query expansion</a:t>
             </a:r>
           </a:p>
           <a:p>
-            <a:pPr lvl="1">
-              <a:lnSpc>
-                <a:spcPct val="115000"/>
-              </a:lnSpc>
-              <a:spcAft>
-                <a:spcPts val="1000"/>
+            <a:pPr lvl="1" algn="l">
+              <a:lnSpc>
+                <a:spcPct val="105000"/>
+              </a:lnSpc>
+              <a:spcAft>
+                <a:spcPts val="300"/>
               </a:spcAft>
             </a:pPr>
             <a:r>
-              <a:rPr sz="1400" b="0" dirty="0">
+              <a:rPr sz="1400" b="0">
                 <a:solidFill>
                   <a:srgbClr val="63637E"/>
                 </a:solidFill>
+                <a:latin typeface="Arial"/>
               </a:rPr>
-              <a:t>Improves recall on ambiguous natural-language queries</a:t>
+              <a:t>Not built this round (out of scope for the submitted pipeline); would need its own recall-impact evaluation before adding</a:t>
             </a:r>
           </a:p>
           <a:p>
-            <a:pPr>
-              <a:lnSpc>
-                <a:spcPct val="115000"/>
-              </a:lnSpc>
-              <a:spcAft>
-                <a:spcPts val="1000"/>
+            <a:pPr algn="l">
+              <a:lnSpc>
+                <a:spcPct val="105000"/>
+              </a:lnSpc>
+              <a:spcAft>
+                <a:spcPts val="300"/>
               </a:spcAft>
             </a:pPr>
             <a:r>
-              <a:rPr sz="1700" b="1" dirty="0">
+              <a:rPr sz="1600" b="1">
                 <a:solidFill>
                   <a:srgbClr val="14142B"/>
                 </a:solidFill>
+                <a:latin typeface="Arial"/>
               </a:rPr>
               <a:t>Package the pipeline as a reusable retrieval service/API</a:t>
             </a:r>
           </a:p>
           <a:p>
-            <a:pPr lvl="1">
-              <a:lnSpc>
-                <a:spcPct val="115000"/>
-              </a:lnSpc>
-              <a:spcAft>
-                <a:spcPts val="1000"/>
+            <a:pPr lvl="1" algn="l">
+              <a:lnSpc>
+                <a:spcPct val="105000"/>
+              </a:lnSpc>
+              <a:spcAft>
+                <a:spcPts val="300"/>
               </a:spcAft>
             </a:pPr>
             <a:r>
-              <a:rPr sz="1400" b="0" dirty="0">
+              <a:rPr sz="1400" b="0">
                 <a:solidFill>
                   <a:srgbClr val="63637E"/>
                 </a:solidFill>
+                <a:latin typeface="Arial"/>
               </a:rPr>
               <a:t>So it can sit behind any coding agent, not just this evaluation harness</a:t>
             </a:r>

</xml_diff>